<commit_message>
fix: the training runs list no longer overflows its slide
The list carried three blank lines and a line that repeated the line above
it, and it was set at 15pt in a box that the text did not fit. The list is
now twelve lines at 14pt, and no shape on any slide of the deck extends past
the edge of the slide.
</commit_message>
<xml_diff>
--- a/report/presentation.pptx
+++ b/report/presentation.pptx
@@ -28135,9 +28135,9 @@
           <a:p>
             <a:pPr>
               <a:spcAft>
-                <a:spcPts val="600"/>
+                <a:spcPts val="400"/>
               </a:spcAft>
-              <a:defRPr sz="1500">
+              <a:defRPr sz="1400">
                 <a:solidFill>
                   <a:srgbClr val="333333"/>
                 </a:solidFill>
@@ -28151,9 +28151,9 @@
           <a:p>
             <a:pPr>
               <a:spcAft>
-                <a:spcPts val="600"/>
+                <a:spcPts val="400"/>
               </a:spcAft>
-              <a:defRPr sz="1500">
+              <a:defRPr sz="1400">
                 <a:solidFill>
                   <a:srgbClr val="333333"/>
                 </a:solidFill>
@@ -28167,9 +28167,9 @@
           <a:p>
             <a:pPr>
               <a:spcAft>
-                <a:spcPts val="600"/>
+                <a:spcPts val="400"/>
               </a:spcAft>
-              <a:defRPr sz="1500">
+              <a:defRPr sz="1400">
                 <a:solidFill>
                   <a:srgbClr val="333333"/>
                 </a:solidFill>
@@ -28183,22 +28183,25 @@
           <a:p>
             <a:pPr>
               <a:spcAft>
-                <a:spcPts val="600"/>
+                <a:spcPts val="400"/>
               </a:spcAft>
-              <a:defRPr sz="1500">
+              <a:defRPr sz="1400">
                 <a:solidFill>
                   <a:srgbClr val="333333"/>
                 </a:solidFill>
                 <a:latin typeface="Calibri"/>
               </a:defRPr>
             </a:pPr>
+            <a:r>
+              <a:t>2️⃣ Ablation grid: 7 weights × 3 seeds = 21 policies</a:t>
+            </a:r>
           </a:p>
           <a:p>
             <a:pPr>
               <a:spcAft>
-                <a:spcPts val="600"/>
+                <a:spcPts val="400"/>
               </a:spcAft>
-              <a:defRPr sz="1500">
+              <a:defRPr sz="1400">
                 <a:solidFill>
                   <a:srgbClr val="333333"/>
                 </a:solidFill>
@@ -28206,15 +28209,15 @@
               </a:defRPr>
             </a:pPr>
             <a:r>
-              <a:t>2️⃣ Ablation grid: 7 weights × 3 seeds = 21 policies</a:t>
+              <a:t>    w₂ ∈ {0.0, 0.2, 0.4, 0.5, 0.6, 0.8, 1.0}</a:t>
             </a:r>
           </a:p>
           <a:p>
             <a:pPr>
               <a:spcAft>
-                <a:spcPts val="600"/>
+                <a:spcPts val="400"/>
               </a:spcAft>
-              <a:defRPr sz="1500">
+              <a:defRPr sz="1400">
                 <a:solidFill>
                   <a:srgbClr val="333333"/>
                 </a:solidFill>
@@ -28222,15 +28225,15 @@
               </a:defRPr>
             </a:pPr>
             <a:r>
-              <a:t>    w₂ ∈ {0.0, 0.2, 0.4, 0.5, 0.6, 0.8, 1.0}</a:t>
+              <a:t>    seeds {42, 43, 44}, 150k steps each</a:t>
             </a:r>
           </a:p>
           <a:p>
             <a:pPr>
               <a:spcAft>
-                <a:spcPts val="600"/>
+                <a:spcPts val="400"/>
               </a:spcAft>
-              <a:defRPr sz="1500">
+              <a:defRPr sz="1400">
                 <a:solidFill>
                   <a:srgbClr val="333333"/>
                 </a:solidFill>
@@ -28238,15 +28241,15 @@
               </a:defRPr>
             </a:pPr>
             <a:r>
-              <a:t>    seeds {42, 43, 44}, 150k steps each</a:t>
+              <a:t>    weight PINNED at training and at evaluation</a:t>
             </a:r>
           </a:p>
           <a:p>
             <a:pPr>
               <a:spcAft>
-                <a:spcPts val="600"/>
+                <a:spcPts val="400"/>
               </a:spcAft>
-              <a:defRPr sz="1500">
+              <a:defRPr sz="1400">
                 <a:solidFill>
                   <a:srgbClr val="333333"/>
                 </a:solidFill>
@@ -28254,15 +28257,15 @@
               </a:defRPr>
             </a:pPr>
             <a:r>
-              <a:t>    weight PINNED at training, evaluated at that</a:t>
+              <a:t>3️⃣ Batch-aware policy: 1M steps on MillingDTBatchEnv-v1</a:t>
             </a:r>
           </a:p>
           <a:p>
             <a:pPr>
               <a:spcAft>
-                <a:spcPts val="600"/>
+                <a:spcPts val="400"/>
               </a:spcAft>
-              <a:defRPr sz="1500">
+              <a:defRPr sz="1400">
                 <a:solidFill>
                   <a:srgbClr val="333333"/>
                 </a:solidFill>
@@ -28270,102 +28273,31 @@
               </a:defRPr>
             </a:pPr>
             <a:r>
-              <a:t>    same weight</a:t>
+              <a:t>4️⃣ Noisy-measurement policy: 1M steps, --obs-noise 0.05</a:t>
             </a:r>
           </a:p>
           <a:p>
             <a:pPr>
               <a:spcAft>
-                <a:spcPts val="600"/>
+                <a:spcPts val="400"/>
               </a:spcAft>
-              <a:defRPr sz="1500">
+              <a:defRPr sz="1400">
                 <a:solidFill>
                   <a:srgbClr val="333333"/>
                 </a:solidFill>
                 <a:latin typeface="Calibri"/>
               </a:defRPr>
             </a:pPr>
+            <a:r>
+              <a:t>Heartbeat callback: queue signal every 1000 steps</a:t>
+            </a:r>
           </a:p>
           <a:p>
             <a:pPr>
               <a:spcAft>
-                <a:spcPts val="600"/>
+                <a:spcPts val="400"/>
               </a:spcAft>
-              <a:defRPr sz="1500">
-                <a:solidFill>
-                  <a:srgbClr val="333333"/>
-                </a:solidFill>
-                <a:latin typeface="Calibri"/>
-              </a:defRPr>
-            </a:pPr>
-            <a:r>
-              <a:t>3️⃣ Batch-aware policy: 1M steps on MillingDTBatchEnv-v1</a:t>
-            </a:r>
-          </a:p>
-          <a:p>
-            <a:pPr>
-              <a:spcAft>
-                <a:spcPts val="600"/>
-              </a:spcAft>
-              <a:defRPr sz="1500">
-                <a:solidFill>
-                  <a:srgbClr val="333333"/>
-                </a:solidFill>
-                <a:latin typeface="Calibri"/>
-              </a:defRPr>
-            </a:pPr>
-          </a:p>
-          <a:p>
-            <a:pPr>
-              <a:spcAft>
-                <a:spcPts val="600"/>
-              </a:spcAft>
-              <a:defRPr sz="1500">
-                <a:solidFill>
-                  <a:srgbClr val="333333"/>
-                </a:solidFill>
-                <a:latin typeface="Calibri"/>
-              </a:defRPr>
-            </a:pPr>
-            <a:r>
-              <a:t>4️⃣ Noisy-measurement policy: 1M steps, --obs-noise 0.05</a:t>
-            </a:r>
-          </a:p>
-          <a:p>
-            <a:pPr>
-              <a:spcAft>
-                <a:spcPts val="600"/>
-              </a:spcAft>
-              <a:defRPr sz="1500">
-                <a:solidFill>
-                  <a:srgbClr val="333333"/>
-                </a:solidFill>
-                <a:latin typeface="Calibri"/>
-              </a:defRPr>
-            </a:pPr>
-          </a:p>
-          <a:p>
-            <a:pPr>
-              <a:spcAft>
-                <a:spcPts val="600"/>
-              </a:spcAft>
-              <a:defRPr sz="1500">
-                <a:solidFill>
-                  <a:srgbClr val="333333"/>
-                </a:solidFill>
-                <a:latin typeface="Calibri"/>
-              </a:defRPr>
-            </a:pPr>
-            <a:r>
-              <a:t>Heartbeat callback: queue signal every 1000 steps</a:t>
-            </a:r>
-          </a:p>
-          <a:p>
-            <a:pPr>
-              <a:spcAft>
-                <a:spcPts val="600"/>
-              </a:spcAft>
-              <a:defRPr sz="1500">
+              <a:defRPr sz="1400">
                 <a:solidFill>
                   <a:srgbClr val="333333"/>
                 </a:solidFill>

</xml_diff>